<commit_message>
Actualiza materiales finales de defensa
Sincroniza presentación, PDF, guion y documentación de defensa con el SWHID archivado y la evaluación F-UJI ejecutada al 88 %.
</commit_message>
<xml_diff>
--- a/09_Defensa/presentacion.pptx
+++ b/09_Defensa/presentacion.pptx
@@ -2034,7 +2034,7 @@
                   <a:srgbClr val="FFFFFF"/>
                 </a:solidFill>
               </a:rPr>
-              <a:t>Defensa Final · Entrega 4 (2B) · Ingeniería de Requerimientos ISR-401</a:t>
+              <a:t>Defensa Final · Entrega 4 (2B) · Ingeniería de Requisitos ISR-401</a:t>
             </a:r>
             <a:endParaRPr lang="en-US" sz="1400" dirty="0"/>
           </a:p>
@@ -6748,24 +6748,13 @@
               <a:buNone/>
             </a:pPr>
             <a:r>
-              <a:rPr sz="1200" b="1">
-                <a:solidFill>
-                  <a:srgbClr val="FFFFFF"/>
-                </a:solidFill>
-              </a:rPr>
               <a:t>Software Heritage</a:t>
             </a:r>
             <a:endParaRPr lang="en-US" sz="1200" dirty="0"/>
           </a:p>
           <a:p>
-            <a:pPr algn="ctr"/>
-            <a:r>
-              <a:rPr sz="1200" b="1">
-                <a:solidFill>
-                  <a:srgbClr val="FFFFFF"/>
-                </a:solidFill>
-              </a:rPr>
-              <a:t>SWHID pendiente</a:t>
+            <a:r>
+              <a:t>SWHID archivado</a:t>
             </a:r>
           </a:p>
         </p:txBody>
@@ -6835,24 +6824,13 @@
               <a:buNone/>
             </a:pPr>
             <a:r>
-              <a:rPr sz="1200" b="1">
-                <a:solidFill>
-                  <a:srgbClr val="FFFFFF"/>
-                </a:solidFill>
-              </a:rPr>
               <a:t>F-UJI</a:t>
             </a:r>
             <a:endParaRPr lang="en-US" sz="1200" dirty="0"/>
           </a:p>
           <a:p>
-            <a:pPr algn="ctr"/>
-            <a:r>
-              <a:rPr sz="1200" b="1">
-                <a:solidFill>
-                  <a:srgbClr val="FFFFFF"/>
-                </a:solidFill>
-              </a:rPr>
-              <a:t>evaluación pendiente</a:t>
+            <a:r>
+              <a:t>88 % · FAIR moderate</a:t>
             </a:r>
           </a:p>
         </p:txBody>
@@ -7049,7 +7027,7 @@
                   <a:srgbClr val="1B1E1C"/>
                 </a:solidFill>
               </a:rPr>
-              <a:t>SWHID y F-UJI se declaran solo cuando exista evidencia real.</a:t>
+              <a:t>Software Heritage cuenta con SWHID archivado y F-UJI fue ejecutado con 88 % (FAIR moderate). Tras el tag terminal se ejecuta Save again para preservar la última revisión.</a:t>
             </a:r>
           </a:p>
         </p:txBody>
@@ -8438,7 +8416,7 @@
                   <a:srgbClr val="1B1E1C"/>
                 </a:solidFill>
               </a:rPr>
-              <a:t>Cerrar SWHID y F-UJI con evidencia verificable, si el docente lo exige.</a:t>
+              <a:t>Ejecutar Save again en Software Heritage después del tag terminal y conservar la evaluación F-UJI 88 % como evidencia FAIR.</a:t>
             </a:r>
           </a:p>
         </p:txBody>
@@ -11501,7 +11479,7 @@
               </a:defRPr>
             </a:pPr>
             <a:r>
-              <a:t>Final Defense 2B</a:t>
+              <a:t>Defensa Final 2B</a:t>
             </a:r>
           </a:p>
         </p:txBody>
@@ -11998,7 +11976,7 @@
               </a:defRPr>
             </a:pPr>
             <a:r>
-              <a:t>Final Defense 2B</a:t>
+              <a:t>Defensa Final 2B</a:t>
             </a:r>
           </a:p>
         </p:txBody>
@@ -12495,7 +12473,7 @@
               </a:defRPr>
             </a:pPr>
             <a:r>
-              <a:t>Final Defense 2B</a:t>
+              <a:t>Defensa Final 2B</a:t>
             </a:r>
           </a:p>
         </p:txBody>

</xml_diff>